<commit_message>
docs(presentation): add Light Mode real screenshot and dedicated daylight accessibility slide
</commit_message>
<xml_diff>
--- a/QuickShare_Presentation.pptx
+++ b/QuickShare_Presentation.pptx
@@ -22,6 +22,7 @@
     <p:sldId id="270" r:id="rId21"/>
     <p:sldId id="271" r:id="rId22"/>
     <p:sldId id="272" r:id="rId23"/>
+    <p:sldId id="273" r:id="rId24"/>
   </p:sldIdLst>
   <p:sldSz cx="12191695" cy="6858000" type="screen4x3"/>
   <p:notesSz cx="6858000" cy="9144000"/>
@@ -5005,7 +5006,7 @@
               </a:defRPr>
             </a:pPr>
             <a:r>
-              <a:t>VISUAL DESIGN</a:t>
+              <a:t>VISUAL ACCESSIBILITY</a:t>
             </a:r>
           </a:p>
         </p:txBody>
@@ -5041,7 +5042,7 @@
               </a:defRPr>
             </a:pPr>
             <a:r>
-              <a:t>Night Mode &amp; Visual Accessibility</a:t>
+              <a:t>Light Mode (Day Theme) Interface</a:t>
             </a:r>
           </a:p>
           <a:p>
@@ -5057,14 +5058,14 @@
               </a:defRPr>
             </a:pPr>
             <a:r>
-              <a:t>Live application screenshot showing the high-contrast dark theme.</a:t>
+              <a:t>Live application screenshot showing the high-contrast daylight theme.</a:t>
             </a:r>
           </a:p>
         </p:txBody>
       </p:sp>
       <p:pic>
         <p:nvPicPr>
-          <p:cNvPr id="5" name="Picture 4" descr="screen_12_night_mode.png"/>
+          <p:cNvPr id="5" name="Picture 4" descr="screen_13_light_mode.png"/>
           <p:cNvPicPr>
             <a:picLocks noChangeAspect="1"/>
           </p:cNvPicPr>
@@ -5162,7 +5163,7 @@
               </a:defRPr>
             </a:pPr>
             <a:r>
-              <a:t>Visual Design &amp; Accessibility Features</a:t>
+              <a:t>Daylight Usability &amp; Interface Features</a:t>
             </a:r>
           </a:p>
           <a:p>
@@ -5178,7 +5179,7 @@
               </a:defRPr>
             </a:pPr>
             <a:r>
-              <a:t>• Ambient radial canvas: Subtle depth mesh designed for extended use.</a:t>
+              <a:t>• Crisp daylight contrast: Pure white canvas and slate typography tuned for bright ambient lighting.</a:t>
             </a:r>
           </a:p>
           <a:p>
@@ -5194,7 +5195,7 @@
               </a:defRPr>
             </a:pPr>
             <a:r>
-              <a:t>• 1-Click theme toggle: Instant switch between Day (Light) and Night (Dark) mode.</a:t>
+              <a:t>• Minimal visual distraction: High-contrast focus boundaries around dropzones and primary buttons.</a:t>
             </a:r>
           </a:p>
           <a:p>
@@ -5210,7 +5211,7 @@
               </a:defRPr>
             </a:pPr>
             <a:r>
-              <a:t>• Persistent user preference: Saved in browser local storage automatically.</a:t>
+              <a:t>• 1-Click theme switcher: Smooth instant transition between Day and Night modes without page reloads.</a:t>
             </a:r>
           </a:p>
           <a:p>
@@ -5226,7 +5227,7 @@
               </a:defRPr>
             </a:pPr>
             <a:r>
-              <a:t>• WCAG-compliant contrast: High-contrast text ensures readable code displays.</a:t>
+              <a:t>• Inter font typography: Clean, modern sans-serif type scales for fast code and file inspection.</a:t>
             </a:r>
           </a:p>
           <a:p>
@@ -5242,7 +5243,7 @@
               </a:defRPr>
             </a:pPr>
             <a:r>
-              <a:t>• Reduced eye strain: Optimal for evening study sessions and low-light labs.</a:t>
+              <a:t>• Consistent component styling: Uniform border radiuses, soft drop shadows, and clean input states.</a:t>
             </a:r>
           </a:p>
           <a:p>
@@ -5258,7 +5259,7 @@
               </a:defRPr>
             </a:pPr>
             <a:r>
-              <a:t>• Consistent UI language across all modals, drawers, and form controls.</a:t>
+              <a:t>• Daytime readability: Prevents glare and visual fatigue during morning lectures and lab sessions.</a:t>
             </a:r>
           </a:p>
         </p:txBody>
@@ -5355,7 +5356,7 @@
               </a:defRPr>
             </a:pPr>
             <a:r>
-              <a:t>ENGINEERING SPECIFICATIONS</a:t>
+              <a:t>VISUAL ACCESSIBILITY</a:t>
             </a:r>
           </a:p>
         </p:txBody>
@@ -5391,7 +5392,7 @@
               </a:defRPr>
             </a:pPr>
             <a:r>
-              <a:t>Technology Stack &amp; ₹0 Cloud Economics</a:t>
+              <a:t>Night Mode (Dark Theme) Interface</a:t>
             </a:r>
           </a:p>
           <a:p>
@@ -5407,21 +5408,45 @@
               </a:defRPr>
             </a:pPr>
             <a:r>
-              <a:t>Demonstrating modern architectural efficiency with zero financial overhead.</a:t>
-            </a:r>
-          </a:p>
-        </p:txBody>
-      </p:sp>
-      <p:sp>
-        <p:nvSpPr>
-          <p:cNvPr id="5" name="Rounded Rectangle 4"/>
+              <a:t>Live application screenshot showing the ambient high-contrast dark theme.</a:t>
+            </a:r>
+          </a:p>
+        </p:txBody>
+      </p:sp>
+      <p:pic>
+        <p:nvPicPr>
+          <p:cNvPr id="5" name="Picture 4" descr="screen_12_night_mode.png"/>
+          <p:cNvPicPr>
+            <a:picLocks noChangeAspect="1"/>
+          </p:cNvPicPr>
+          <p:nvPr/>
+        </p:nvPicPr>
+        <p:blipFill>
+          <a:blip r:embed="rId2"/>
+          <a:stretch>
+            <a:fillRect/>
+          </a:stretch>
+        </p:blipFill>
+        <p:spPr>
+          <a:xfrm>
+            <a:off x="731520" y="1645920"/>
+            <a:ext cx="6858000" cy="4572000"/>
+          </a:xfrm>
+          <a:prstGeom prst="rect">
+            <a:avLst/>
+          </a:prstGeom>
+        </p:spPr>
+      </p:pic>
+      <p:sp>
+        <p:nvSpPr>
+          <p:cNvPr id="6" name="Rounded Rectangle 5"/>
           <p:cNvSpPr/>
           <p:nvPr/>
         </p:nvSpPr>
         <p:spPr>
           <a:xfrm>
-            <a:off x="731520" y="1645920"/>
-            <a:ext cx="2011680" cy="4389120"/>
+            <a:off x="7863840" y="1645920"/>
+            <a:ext cx="3566160" cy="4572000"/>
           </a:xfrm>
           <a:prstGeom prst="roundRect">
             <a:avLst/>
@@ -5429,7 +5454,7 @@
           <a:solidFill>
             <a:srgbClr val="1E293B"/>
           </a:solidFill>
-          <a:ln>
+          <a:ln w="12700">
             <a:solidFill>
               <a:srgbClr val="334155"/>
             </a:solidFill>
@@ -5459,14 +5484,14 @@
       </p:sp>
       <p:sp>
         <p:nvSpPr>
-          <p:cNvPr id="6" name="TextBox 5"/>
+          <p:cNvPr id="7" name="TextBox 6"/>
           <p:cNvSpPr txBox="1"/>
           <p:nvPr/>
         </p:nvSpPr>
         <p:spPr>
           <a:xfrm>
-            <a:off x="868680" y="1920240"/>
-            <a:ext cx="1737360" cy="3840480"/>
+            <a:off x="8183880" y="1874519"/>
+            <a:ext cx="2926080" cy="4114800"/>
           </a:xfrm>
           <a:prstGeom prst="rect">
             <a:avLst/>
@@ -5479,8 +5504,8 @@
           </a:bodyPr>
           <a:lstStyle/>
           <a:p>
-            <a:pPr algn="ctr">
-              <a:defRPr sz="2600" b="1">
+            <a:pPr>
+              <a:defRPr sz="1400" b="1">
                 <a:solidFill>
                   <a:srgbClr val="F43F5E"/>
                 </a:solidFill>
@@ -5488,521 +5513,103 @@
               </a:defRPr>
             </a:pPr>
             <a:r>
-              <a:t>₹0 / Month</a:t>
-            </a:r>
-          </a:p>
-          <a:p>
-            <a:pPr algn="ctr">
-              <a:spcBef>
-                <a:spcPts val="800"/>
-              </a:spcBef>
-              <a:defRPr sz="1200" b="1">
-                <a:solidFill>
-                  <a:srgbClr val="FFFFFF"/>
-                </a:solidFill>
-              </a:defRPr>
-            </a:pPr>
-            <a:r>
-              <a:t>Total Hosting Cost</a:t>
-            </a:r>
-          </a:p>
-          <a:p>
-            <a:pPr algn="ctr">
-              <a:spcBef>
-                <a:spcPts val="1400"/>
-              </a:spcBef>
-              <a:defRPr sz="1100">
-                <a:solidFill>
-                  <a:srgbClr val="94A3B8"/>
-                </a:solidFill>
-              </a:defRPr>
-            </a:pPr>
-            <a:r>
-              <a:t>100% Free Forever</a:t>
-            </a:r>
-            <a:br/>
-            <a:r>
-              <a:t>No credit card required</a:t>
-            </a:r>
-            <a:br/>
-            <a:r>
-              <a:t>Production-ready SLA</a:t>
-            </a:r>
-          </a:p>
-        </p:txBody>
-      </p:sp>
-      <p:sp>
-        <p:nvSpPr>
-          <p:cNvPr id="7" name="Rounded Rectangle 6"/>
-          <p:cNvSpPr/>
-          <p:nvPr/>
-        </p:nvSpPr>
-        <p:spPr>
-          <a:xfrm>
-            <a:off x="2907791" y="1645920"/>
-            <a:ext cx="2011680" cy="4389120"/>
-          </a:xfrm>
-          <a:prstGeom prst="roundRect">
-            <a:avLst/>
-          </a:prstGeom>
-          <a:solidFill>
-            <a:srgbClr val="1E293B"/>
-          </a:solidFill>
-          <a:ln>
-            <a:solidFill>
-              <a:srgbClr val="334155"/>
-            </a:solidFill>
-          </a:ln>
-        </p:spPr>
-        <p:style>
-          <a:lnRef idx="1">
-            <a:schemeClr val="accent1"/>
-          </a:lnRef>
-          <a:fillRef idx="3">
-            <a:schemeClr val="accent1"/>
-          </a:fillRef>
-          <a:effectRef idx="2">
-            <a:schemeClr val="accent1"/>
-          </a:effectRef>
-          <a:fontRef idx="minor">
-            <a:schemeClr val="lt1"/>
-          </a:fontRef>
-        </p:style>
-        <p:txBody>
-          <a:bodyPr rtlCol="0" anchor="ctr"/>
-          <a:lstStyle/>
-          <a:p>
-            <a:pPr algn="ctr"/>
-          </a:p>
-        </p:txBody>
-      </p:sp>
-      <p:sp>
-        <p:nvSpPr>
-          <p:cNvPr id="8" name="TextBox 7"/>
-          <p:cNvSpPr txBox="1"/>
-          <p:nvPr/>
-        </p:nvSpPr>
-        <p:spPr>
-          <a:xfrm>
-            <a:off x="3044951" y="1920240"/>
-            <a:ext cx="1737360" cy="3840480"/>
-          </a:xfrm>
-          <a:prstGeom prst="rect">
-            <a:avLst/>
-          </a:prstGeom>
-          <a:noFill/>
-        </p:spPr>
-        <p:txBody>
-          <a:bodyPr wrap="square">
-            <a:spAutoFit/>
-          </a:bodyPr>
-          <a:lstStyle/>
-          <a:p>
-            <a:pPr algn="ctr">
-              <a:defRPr sz="2600" b="1">
-                <a:solidFill>
-                  <a:srgbClr val="818CF8"/>
-                </a:solidFill>
-                <a:latin typeface="Segoe UI"/>
-              </a:defRPr>
-            </a:pPr>
-            <a:r>
-              <a:t>100 GB</a:t>
-            </a:r>
-          </a:p>
-          <a:p>
-            <a:pPr algn="ctr">
-              <a:spcBef>
-                <a:spcPts val="800"/>
-              </a:spcBef>
-              <a:defRPr sz="1200" b="1">
-                <a:solidFill>
-                  <a:srgbClr val="FFFFFF"/>
-                </a:solidFill>
-              </a:defRPr>
-            </a:pPr>
-            <a:r>
-              <a:t>Vercel Edge CDN</a:t>
-            </a:r>
-          </a:p>
-          <a:p>
-            <a:pPr algn="ctr">
-              <a:spcBef>
-                <a:spcPts val="1400"/>
-              </a:spcBef>
-              <a:defRPr sz="1100">
-                <a:solidFill>
-                  <a:srgbClr val="94A3B8"/>
-                </a:solidFill>
-              </a:defRPr>
-            </a:pPr>
-            <a:r>
-              <a:t>React 18 &amp; Vite SPA</a:t>
-            </a:r>
-            <a:br/>
-            <a:r>
-              <a:t>Global edge caching</a:t>
-            </a:r>
-            <a:br/>
-            <a:r>
-              <a:t>Automatic SSL &amp; CI/CD</a:t>
-            </a:r>
-          </a:p>
-        </p:txBody>
-      </p:sp>
-      <p:sp>
-        <p:nvSpPr>
-          <p:cNvPr id="9" name="Rounded Rectangle 8"/>
-          <p:cNvSpPr/>
-          <p:nvPr/>
-        </p:nvSpPr>
-        <p:spPr>
-          <a:xfrm>
-            <a:off x="5084064" y="1645920"/>
-            <a:ext cx="2011680" cy="4389120"/>
-          </a:xfrm>
-          <a:prstGeom prst="roundRect">
-            <a:avLst/>
-          </a:prstGeom>
-          <a:solidFill>
-            <a:srgbClr val="1E293B"/>
-          </a:solidFill>
-          <a:ln>
-            <a:solidFill>
-              <a:srgbClr val="334155"/>
-            </a:solidFill>
-          </a:ln>
-        </p:spPr>
-        <p:style>
-          <a:lnRef idx="1">
-            <a:schemeClr val="accent1"/>
-          </a:lnRef>
-          <a:fillRef idx="3">
-            <a:schemeClr val="accent1"/>
-          </a:fillRef>
-          <a:effectRef idx="2">
-            <a:schemeClr val="accent1"/>
-          </a:effectRef>
-          <a:fontRef idx="minor">
-            <a:schemeClr val="lt1"/>
-          </a:fontRef>
-        </p:style>
-        <p:txBody>
-          <a:bodyPr rtlCol="0" anchor="ctr"/>
-          <a:lstStyle/>
-          <a:p>
-            <a:pPr algn="ctr"/>
-          </a:p>
-        </p:txBody>
-      </p:sp>
-      <p:sp>
-        <p:nvSpPr>
-          <p:cNvPr id="10" name="TextBox 9"/>
-          <p:cNvSpPr txBox="1"/>
-          <p:nvPr/>
-        </p:nvSpPr>
-        <p:spPr>
-          <a:xfrm>
-            <a:off x="5221224" y="1920240"/>
-            <a:ext cx="1737360" cy="3840480"/>
-          </a:xfrm>
-          <a:prstGeom prst="rect">
-            <a:avLst/>
-          </a:prstGeom>
-          <a:noFill/>
-        </p:spPr>
-        <p:txBody>
-          <a:bodyPr wrap="square">
-            <a:spAutoFit/>
-          </a:bodyPr>
-          <a:lstStyle/>
-          <a:p>
-            <a:pPr algn="ctr">
-              <a:defRPr sz="2600" b="1">
-                <a:solidFill>
-                  <a:srgbClr val="10B981"/>
-                </a:solidFill>
-                <a:latin typeface="Segoe UI"/>
-              </a:defRPr>
-            </a:pPr>
-            <a:r>
-              <a:t>512 MB</a:t>
-            </a:r>
-          </a:p>
-          <a:p>
-            <a:pPr algn="ctr">
-              <a:spcBef>
-                <a:spcPts val="800"/>
-              </a:spcBef>
-              <a:defRPr sz="1200" b="1">
-                <a:solidFill>
-                  <a:srgbClr val="FFFFFF"/>
-                </a:solidFill>
-              </a:defRPr>
-            </a:pPr>
-            <a:r>
-              <a:t>Render API Service</a:t>
-            </a:r>
-          </a:p>
-          <a:p>
-            <a:pPr algn="ctr">
-              <a:spcBef>
-                <a:spcPts val="1400"/>
-              </a:spcBef>
-              <a:defRPr sz="1100">
-                <a:solidFill>
-                  <a:srgbClr val="94A3B8"/>
-                </a:solidFill>
-              </a:defRPr>
-            </a:pPr>
-            <a:r>
-              <a:t>Node.js 22+ &amp; Express</a:t>
-            </a:r>
-            <a:br/>
-            <a:r>
-              <a:t>REST API &amp; WebSockets</a:t>
-            </a:r>
-            <a:br/>
-            <a:r>
-              <a:t>750 free hours/month</a:t>
-            </a:r>
-          </a:p>
-        </p:txBody>
-      </p:sp>
-      <p:sp>
-        <p:nvSpPr>
-          <p:cNvPr id="11" name="Rounded Rectangle 10"/>
-          <p:cNvSpPr/>
-          <p:nvPr/>
-        </p:nvSpPr>
-        <p:spPr>
-          <a:xfrm>
-            <a:off x="7260336" y="1645920"/>
-            <a:ext cx="2011680" cy="4389120"/>
-          </a:xfrm>
-          <a:prstGeom prst="roundRect">
-            <a:avLst/>
-          </a:prstGeom>
-          <a:solidFill>
-            <a:srgbClr val="1E293B"/>
-          </a:solidFill>
-          <a:ln>
-            <a:solidFill>
-              <a:srgbClr val="334155"/>
-            </a:solidFill>
-          </a:ln>
-        </p:spPr>
-        <p:style>
-          <a:lnRef idx="1">
-            <a:schemeClr val="accent1"/>
-          </a:lnRef>
-          <a:fillRef idx="3">
-            <a:schemeClr val="accent1"/>
-          </a:fillRef>
-          <a:effectRef idx="2">
-            <a:schemeClr val="accent1"/>
-          </a:effectRef>
-          <a:fontRef idx="minor">
-            <a:schemeClr val="lt1"/>
-          </a:fontRef>
-        </p:style>
-        <p:txBody>
-          <a:bodyPr rtlCol="0" anchor="ctr"/>
-          <a:lstStyle/>
-          <a:p>
-            <a:pPr algn="ctr"/>
-          </a:p>
-        </p:txBody>
-      </p:sp>
-      <p:sp>
-        <p:nvSpPr>
-          <p:cNvPr id="12" name="TextBox 11"/>
-          <p:cNvSpPr txBox="1"/>
-          <p:nvPr/>
-        </p:nvSpPr>
-        <p:spPr>
-          <a:xfrm>
-            <a:off x="7397496" y="1920240"/>
-            <a:ext cx="1737360" cy="3840480"/>
-          </a:xfrm>
-          <a:prstGeom prst="rect">
-            <a:avLst/>
-          </a:prstGeom>
-          <a:noFill/>
-        </p:spPr>
-        <p:txBody>
-          <a:bodyPr wrap="square">
-            <a:spAutoFit/>
-          </a:bodyPr>
-          <a:lstStyle/>
-          <a:p>
-            <a:pPr algn="ctr">
-              <a:defRPr sz="2600" b="1">
-                <a:solidFill>
-                  <a:srgbClr val="F43F5E"/>
-                </a:solidFill>
-                <a:latin typeface="Segoe UI"/>
-              </a:defRPr>
-            </a:pPr>
-            <a:r>
-              <a:t>5 GB</a:t>
-            </a:r>
-          </a:p>
-          <a:p>
-            <a:pPr algn="ctr">
-              <a:spcBef>
-                <a:spcPts val="800"/>
-              </a:spcBef>
-              <a:defRPr sz="1200" b="1">
-                <a:solidFill>
-                  <a:srgbClr val="FFFFFF"/>
-                </a:solidFill>
-              </a:defRPr>
-            </a:pPr>
-            <a:r>
-              <a:t>TiDB Serverless</a:t>
-            </a:r>
-          </a:p>
-          <a:p>
-            <a:pPr algn="ctr">
-              <a:spcBef>
-                <a:spcPts val="1400"/>
-              </a:spcBef>
-              <a:defRPr sz="1100">
-                <a:solidFill>
-                  <a:srgbClr val="94A3B8"/>
-                </a:solidFill>
-              </a:defRPr>
-            </a:pPr>
-            <a:r>
-              <a:t>Cloud MySQL 8 engine</a:t>
-            </a:r>
-            <a:br/>
-            <a:r>
-              <a:t>50M Request Units/month</a:t>
-            </a:r>
-            <a:br/>
-            <a:r>
-              <a:t>Dual SQLite dev driver</a:t>
-            </a:r>
-          </a:p>
-        </p:txBody>
-      </p:sp>
-      <p:sp>
-        <p:nvSpPr>
-          <p:cNvPr id="13" name="Rounded Rectangle 12"/>
-          <p:cNvSpPr/>
-          <p:nvPr/>
-        </p:nvSpPr>
-        <p:spPr>
-          <a:xfrm>
-            <a:off x="9436608" y="1645920"/>
-            <a:ext cx="2011680" cy="4389120"/>
-          </a:xfrm>
-          <a:prstGeom prst="roundRect">
-            <a:avLst/>
-          </a:prstGeom>
-          <a:solidFill>
-            <a:srgbClr val="1E293B"/>
-          </a:solidFill>
-          <a:ln>
-            <a:solidFill>
-              <a:srgbClr val="334155"/>
-            </a:solidFill>
-          </a:ln>
-        </p:spPr>
-        <p:style>
-          <a:lnRef idx="1">
-            <a:schemeClr val="accent1"/>
-          </a:lnRef>
-          <a:fillRef idx="3">
-            <a:schemeClr val="accent1"/>
-          </a:fillRef>
-          <a:effectRef idx="2">
-            <a:schemeClr val="accent1"/>
-          </a:effectRef>
-          <a:fontRef idx="minor">
-            <a:schemeClr val="lt1"/>
-          </a:fontRef>
-        </p:style>
-        <p:txBody>
-          <a:bodyPr rtlCol="0" anchor="ctr"/>
-          <a:lstStyle/>
-          <a:p>
-            <a:pPr algn="ctr"/>
-          </a:p>
-        </p:txBody>
-      </p:sp>
-      <p:sp>
-        <p:nvSpPr>
-          <p:cNvPr id="14" name="TextBox 13"/>
-          <p:cNvSpPr txBox="1"/>
-          <p:nvPr/>
-        </p:nvSpPr>
-        <p:spPr>
-          <a:xfrm>
-            <a:off x="9573768" y="1920240"/>
-            <a:ext cx="1737360" cy="3840480"/>
-          </a:xfrm>
-          <a:prstGeom prst="rect">
-            <a:avLst/>
-          </a:prstGeom>
-          <a:noFill/>
-        </p:spPr>
-        <p:txBody>
-          <a:bodyPr wrap="square">
-            <a:spAutoFit/>
-          </a:bodyPr>
-          <a:lstStyle/>
-          <a:p>
-            <a:pPr algn="ctr">
-              <a:defRPr sz="2600" b="1">
-                <a:solidFill>
-                  <a:srgbClr val="818CF8"/>
-                </a:solidFill>
-                <a:latin typeface="Segoe UI"/>
-              </a:defRPr>
-            </a:pPr>
-            <a:r>
-              <a:t>1 GB</a:t>
-            </a:r>
-          </a:p>
-          <a:p>
-            <a:pPr algn="ctr">
-              <a:spcBef>
-                <a:spcPts val="800"/>
-              </a:spcBef>
-              <a:defRPr sz="1200" b="1">
-                <a:solidFill>
-                  <a:srgbClr val="FFFFFF"/>
-                </a:solidFill>
-              </a:defRPr>
-            </a:pPr>
-            <a:r>
-              <a:t>Supabase S3 Storage</a:t>
-            </a:r>
-          </a:p>
-          <a:p>
-            <a:pPr algn="ctr">
-              <a:spcBef>
-                <a:spcPts val="1400"/>
-              </a:spcBef>
-              <a:defRPr sz="1100">
-                <a:solidFill>
-                  <a:srgbClr val="94A3B8"/>
-                </a:solidFill>
-              </a:defRPr>
-            </a:pPr>
-            <a:r>
-              <a:t>S3-compatible bucket</a:t>
-            </a:r>
-            <a:br/>
-            <a:r>
-              <a:t>Streaming downloads</a:t>
-            </a:r>
-            <a:br/>
-            <a:r>
-              <a:t>Automated purge cron</a:t>
+              <a:t>Low-Light Ergonomics &amp; Eye-Care Features</a:t>
+            </a:r>
+          </a:p>
+          <a:p>
+            <a:pPr>
+              <a:spcBef>
+                <a:spcPts val="600"/>
+              </a:spcBef>
+              <a:defRPr sz="1100">
+                <a:solidFill>
+                  <a:srgbClr val="E2E8F0"/>
+                </a:solidFill>
+                <a:latin typeface="Segoe UI"/>
+              </a:defRPr>
+            </a:pPr>
+            <a:r>
+              <a:t>• Ambient radial canvas: Deep obsidian background with subtle indigo gradients.</a:t>
+            </a:r>
+          </a:p>
+          <a:p>
+            <a:pPr>
+              <a:spcBef>
+                <a:spcPts val="600"/>
+              </a:spcBef>
+              <a:defRPr sz="1100">
+                <a:solidFill>
+                  <a:srgbClr val="E2E8F0"/>
+                </a:solidFill>
+                <a:latin typeface="Segoe UI"/>
+              </a:defRPr>
+            </a:pPr>
+            <a:r>
+              <a:t>• Reduced eye strain: Prevents glare during evening study hours and low-light environments.</a:t>
+            </a:r>
+          </a:p>
+          <a:p>
+            <a:pPr>
+              <a:spcBef>
+                <a:spcPts val="600"/>
+              </a:spcBef>
+              <a:defRPr sz="1100">
+                <a:solidFill>
+                  <a:srgbClr val="E2E8F0"/>
+                </a:solidFill>
+                <a:latin typeface="Segoe UI"/>
+              </a:defRPr>
+            </a:pPr>
+            <a:r>
+              <a:t>• OLED power efficiency: Reduces battery draw on modern smartphone and laptop displays.</a:t>
+            </a:r>
+          </a:p>
+          <a:p>
+            <a:pPr>
+              <a:spcBef>
+                <a:spcPts val="600"/>
+              </a:spcBef>
+              <a:defRPr sz="1100">
+                <a:solidFill>
+                  <a:srgbClr val="E2E8F0"/>
+                </a:solidFill>
+                <a:latin typeface="Segoe UI"/>
+              </a:defRPr>
+            </a:pPr>
+            <a:r>
+              <a:t>• High-contrast text tokens: Crisp white headers and neon accents ensure legible 6-digit codes.</a:t>
+            </a:r>
+          </a:p>
+          <a:p>
+            <a:pPr>
+              <a:spcBef>
+                <a:spcPts val="600"/>
+              </a:spcBef>
+              <a:defRPr sz="1100">
+                <a:solidFill>
+                  <a:srgbClr val="E2E8F0"/>
+                </a:solidFill>
+                <a:latin typeface="Segoe UI"/>
+              </a:defRPr>
+            </a:pPr>
+            <a:r>
+              <a:t>• Persistent preference: Theme choice is automatically saved in browser local storage.</a:t>
+            </a:r>
+          </a:p>
+          <a:p>
+            <a:pPr>
+              <a:spcBef>
+                <a:spcPts val="600"/>
+              </a:spcBef>
+              <a:defRPr sz="1100">
+                <a:solidFill>
+                  <a:srgbClr val="E2E8F0"/>
+                </a:solidFill>
+                <a:latin typeface="Segoe UI"/>
+              </a:defRPr>
+            </a:pPr>
+            <a:r>
+              <a:t>• Uniform dark elements: Perfectly styled modals, dialogs, dropdowns, and file cards.</a:t>
             </a:r>
           </a:p>
         </p:txBody>
@@ -6099,7 +5706,7 @@
               </a:defRPr>
             </a:pPr>
             <a:r>
-              <a:t>PRODUCTION VERIFICATION</a:t>
+              <a:t>ENGINEERING SPECIFICATIONS</a:t>
             </a:r>
           </a:p>
         </p:txBody>
@@ -6135,7 +5742,7 @@
               </a:defRPr>
             </a:pPr>
             <a:r>
-              <a:t>Automated Testing &amp; Live Deployment Proof</a:t>
+              <a:t>Technology Stack &amp; ₹0 Cloud Economics</a:t>
             </a:r>
           </a:p>
           <a:p>
@@ -6151,7 +5758,7 @@
               </a:defRPr>
             </a:pPr>
             <a:r>
-              <a:t>Validated through comprehensive test suites and active cloud deployment.</a:t>
+              <a:t>Demonstrating modern architectural efficiency with zero financial overhead.</a:t>
             </a:r>
           </a:p>
         </p:txBody>
@@ -6165,7 +5772,7 @@
         <p:spPr>
           <a:xfrm>
             <a:off x="731520" y="1645920"/>
-            <a:ext cx="3383280" cy="4389120"/>
+            <a:ext cx="2011680" cy="4389120"/>
           </a:xfrm>
           <a:prstGeom prst="roundRect">
             <a:avLst/>
@@ -6209,8 +5816,8 @@
         </p:nvSpPr>
         <p:spPr>
           <a:xfrm>
-            <a:off x="960120" y="1828800"/>
-            <a:ext cx="2926080" cy="4023360"/>
+            <a:off x="868680" y="1920240"/>
+            <a:ext cx="1737360" cy="3840480"/>
           </a:xfrm>
           <a:prstGeom prst="rect">
             <a:avLst/>
@@ -6223,121 +5830,54 @@
           </a:bodyPr>
           <a:lstStyle/>
           <a:p>
-            <a:pPr>
-              <a:defRPr sz="1300" b="1">
-                <a:solidFill>
-                  <a:srgbClr val="10B981"/>
-                </a:solidFill>
-                <a:latin typeface="Segoe UI"/>
-              </a:defRPr>
-            </a:pPr>
-            <a:r>
-              <a:t>Automated Test Coverage</a:t>
-            </a:r>
-          </a:p>
-          <a:p>
-            <a:pPr>
-              <a:spcBef>
-                <a:spcPts val="400"/>
-              </a:spcBef>
-              <a:defRPr sz="1100">
-                <a:solidFill>
-                  <a:srgbClr val="E2E8F0"/>
-                </a:solidFill>
-              </a:defRPr>
-            </a:pPr>
-            <a:r>
-              <a:t>• 53 / 53 Jest automated platform tests passing (100%).</a:t>
-            </a:r>
-          </a:p>
-          <a:p>
-            <a:pPr>
-              <a:spcBef>
-                <a:spcPts val="400"/>
-              </a:spcBef>
-              <a:defRPr sz="1100">
-                <a:solidFill>
-                  <a:srgbClr val="E2E8F0"/>
-                </a:solidFill>
-              </a:defRPr>
-            </a:pPr>
-            <a:r>
-              <a:t>• Authentication: Registration, bcrypt hashing, JWT issuance.</a:t>
-            </a:r>
-          </a:p>
-          <a:p>
-            <a:pPr>
-              <a:spcBef>
-                <a:spcPts val="400"/>
-              </a:spcBef>
-              <a:defRPr sz="1100">
-                <a:solidFill>
-                  <a:srgbClr val="E2E8F0"/>
-                </a:solidFill>
-              </a:defRPr>
-            </a:pPr>
-            <a:r>
-              <a:t>• Upload engine: File sanitization, SHA-256 hashes, size quotas.</a:t>
-            </a:r>
-          </a:p>
-          <a:p>
-            <a:pPr>
-              <a:spcBef>
-                <a:spcPts val="400"/>
-              </a:spcBef>
-              <a:defRPr sz="1100">
-                <a:solidFill>
-                  <a:srgbClr val="E2E8F0"/>
-                </a:solidFill>
-              </a:defRPr>
-            </a:pPr>
-            <a:r>
-              <a:t>• 6-Digit codes: Code lookup, rate limiting, and expiry lockout.</a:t>
-            </a:r>
-          </a:p>
-          <a:p>
-            <a:pPr>
-              <a:spcBef>
-                <a:spcPts val="400"/>
-              </a:spcBef>
-              <a:defRPr sz="1100">
-                <a:solidFill>
-                  <a:srgbClr val="E2E8F0"/>
-                </a:solidFill>
-              </a:defRPr>
-            </a:pPr>
-            <a:r>
-              <a:t>• Direct inboxes: Delivery checkmarks and view updates.</a:t>
-            </a:r>
-          </a:p>
-          <a:p>
-            <a:pPr>
-              <a:spcBef>
-                <a:spcPts val="400"/>
-              </a:spcBef>
-              <a:defRPr sz="1100">
-                <a:solidFill>
-                  <a:srgbClr val="E2E8F0"/>
-                </a:solidFill>
-              </a:defRPr>
-            </a:pPr>
-            <a:r>
-              <a:t>• File drive: Inline rename, trash soft-delete, and restore.</a:t>
-            </a:r>
-          </a:p>
-          <a:p>
-            <a:pPr>
-              <a:spcBef>
-                <a:spcPts val="400"/>
-              </a:spcBef>
-              <a:defRPr sz="1100">
-                <a:solidFill>
-                  <a:srgbClr val="E2E8F0"/>
-                </a:solidFill>
-              </a:defRPr>
-            </a:pPr>
-            <a:r>
-              <a:t>• Group collaboration: Chat messages, roles, and file deletion.</a:t>
+            <a:pPr algn="ctr">
+              <a:defRPr sz="2600" b="1">
+                <a:solidFill>
+                  <a:srgbClr val="F43F5E"/>
+                </a:solidFill>
+                <a:latin typeface="Segoe UI"/>
+              </a:defRPr>
+            </a:pPr>
+            <a:r>
+              <a:t>₹0 / Month</a:t>
+            </a:r>
+          </a:p>
+          <a:p>
+            <a:pPr algn="ctr">
+              <a:spcBef>
+                <a:spcPts val="800"/>
+              </a:spcBef>
+              <a:defRPr sz="1200" b="1">
+                <a:solidFill>
+                  <a:srgbClr val="FFFFFF"/>
+                </a:solidFill>
+              </a:defRPr>
+            </a:pPr>
+            <a:r>
+              <a:t>Total Hosting Cost</a:t>
+            </a:r>
+          </a:p>
+          <a:p>
+            <a:pPr algn="ctr">
+              <a:spcBef>
+                <a:spcPts val="1400"/>
+              </a:spcBef>
+              <a:defRPr sz="1100">
+                <a:solidFill>
+                  <a:srgbClr val="94A3B8"/>
+                </a:solidFill>
+              </a:defRPr>
+            </a:pPr>
+            <a:r>
+              <a:t>100% Free Forever</a:t>
+            </a:r>
+            <a:br/>
+            <a:r>
+              <a:t>No credit card required</a:t>
+            </a:r>
+            <a:br/>
+            <a:r>
+              <a:t>Production-ready SLA</a:t>
             </a:r>
           </a:p>
         </p:txBody>
@@ -6350,8 +5890,8 @@
         </p:nvSpPr>
         <p:spPr>
           <a:xfrm>
-            <a:off x="4389120" y="1645920"/>
-            <a:ext cx="3383280" cy="4389120"/>
+            <a:off x="2907791" y="1645920"/>
+            <a:ext cx="2011680" cy="4389120"/>
           </a:xfrm>
           <a:prstGeom prst="roundRect">
             <a:avLst/>
@@ -6395,8 +5935,8 @@
         </p:nvSpPr>
         <p:spPr>
           <a:xfrm>
-            <a:off x="4617720" y="1828800"/>
-            <a:ext cx="2926080" cy="4023360"/>
+            <a:off x="3044951" y="1920240"/>
+            <a:ext cx="1737360" cy="3840480"/>
           </a:xfrm>
           <a:prstGeom prst="rect">
             <a:avLst/>
@@ -6409,8 +5949,8 @@
           </a:bodyPr>
           <a:lstStyle/>
           <a:p>
-            <a:pPr>
-              <a:defRPr sz="1300" b="1">
+            <a:pPr algn="ctr">
+              <a:defRPr sz="2600" b="1">
                 <a:solidFill>
                   <a:srgbClr val="818CF8"/>
                 </a:solidFill>
@@ -6418,97 +5958,45 @@
               </a:defRPr>
             </a:pPr>
             <a:r>
-              <a:t>Security Verification</a:t>
-            </a:r>
-          </a:p>
-          <a:p>
-            <a:pPr>
-              <a:spcBef>
-                <a:spcPts val="400"/>
-              </a:spcBef>
-              <a:defRPr sz="1100">
-                <a:solidFill>
-                  <a:srgbClr val="E2E8F0"/>
-                </a:solidFill>
-              </a:defRPr>
-            </a:pPr>
-            <a:r>
-              <a:t>• High-entropy tokens: 128-bit share tokens (crypto.randomBytes).</a:t>
-            </a:r>
-          </a:p>
-          <a:p>
-            <a:pPr>
-              <a:spcBef>
-                <a:spcPts val="400"/>
-              </a:spcBef>
-              <a:defRPr sz="1100">
-                <a:solidFill>
-                  <a:srgbClr val="E2E8F0"/>
-                </a:solidFill>
-              </a:defRPr>
-            </a:pPr>
-            <a:r>
-              <a:t>• Owner secret key: 192-bit private token for physical purge.</a:t>
-            </a:r>
-          </a:p>
-          <a:p>
-            <a:pPr>
-              <a:spcBef>
-                <a:spcPts val="400"/>
-              </a:spcBef>
-              <a:defRPr sz="1100">
-                <a:solidFill>
-                  <a:srgbClr val="E2E8F0"/>
-                </a:solidFill>
-              </a:defRPr>
-            </a:pPr>
-            <a:r>
-              <a:t>• Immediate physical purge: Revocation returns HTTP 410 Gone.</a:t>
-            </a:r>
-          </a:p>
-          <a:p>
-            <a:pPr>
-              <a:spcBef>
-                <a:spcPts val="400"/>
-              </a:spcBef>
-              <a:defRPr sz="1100">
-                <a:solidFill>
-                  <a:srgbClr val="E2E8F0"/>
-                </a:solidFill>
-              </a:defRPr>
-            </a:pPr>
-            <a:r>
-              <a:t>• File blocklist: Blocks .exe, .bat, .sh, .vbs, .msi, and .php.</a:t>
-            </a:r>
-          </a:p>
-          <a:p>
-            <a:pPr>
-              <a:spcBef>
-                <a:spcPts val="400"/>
-              </a:spcBef>
-              <a:defRPr sz="1100">
-                <a:solidFill>
-                  <a:srgbClr val="E2E8F0"/>
-                </a:solidFill>
-              </a:defRPr>
-            </a:pPr>
-            <a:r>
-              <a:t>• Parameterized queries: 100% protection against SQL injection.</a:t>
-            </a:r>
-          </a:p>
-          <a:p>
-            <a:pPr>
-              <a:spcBef>
-                <a:spcPts val="400"/>
-              </a:spcBef>
-              <a:defRPr sz="1100">
-                <a:solidFill>
-                  <a:srgbClr val="E2E8F0"/>
-                </a:solidFill>
-              </a:defRPr>
-            </a:pPr>
-            <a:r>
-              <a:t>• Path traversal protection: Strict resolution against upload roots.</a:t>
+              <a:t>100 GB</a:t>
+            </a:r>
+          </a:p>
+          <a:p>
+            <a:pPr algn="ctr">
+              <a:spcBef>
+                <a:spcPts val="800"/>
+              </a:spcBef>
+              <a:defRPr sz="1200" b="1">
+                <a:solidFill>
+                  <a:srgbClr val="FFFFFF"/>
+                </a:solidFill>
+              </a:defRPr>
+            </a:pPr>
+            <a:r>
+              <a:t>Vercel Edge CDN</a:t>
+            </a:r>
+          </a:p>
+          <a:p>
+            <a:pPr algn="ctr">
+              <a:spcBef>
+                <a:spcPts val="1400"/>
+              </a:spcBef>
+              <a:defRPr sz="1100">
+                <a:solidFill>
+                  <a:srgbClr val="94A3B8"/>
+                </a:solidFill>
+              </a:defRPr>
+            </a:pPr>
+            <a:r>
+              <a:t>React 18 &amp; Vite SPA</a:t>
+            </a:r>
+            <a:br/>
+            <a:r>
+              <a:t>Global edge caching</a:t>
+            </a:r>
+            <a:br/>
+            <a:r>
+              <a:t>Automatic SSL &amp; CI/CD</a:t>
             </a:r>
           </a:p>
         </p:txBody>
@@ -6521,8 +6009,8 @@
         </p:nvSpPr>
         <p:spPr>
           <a:xfrm>
-            <a:off x="8046720" y="1645920"/>
-            <a:ext cx="3383280" cy="4389120"/>
+            <a:off x="5084064" y="1645920"/>
+            <a:ext cx="2011680" cy="4389120"/>
           </a:xfrm>
           <a:prstGeom prst="roundRect">
             <a:avLst/>
@@ -6566,8 +6054,8 @@
         </p:nvSpPr>
         <p:spPr>
           <a:xfrm>
-            <a:off x="8275320" y="1828800"/>
-            <a:ext cx="2926080" cy="4023360"/>
+            <a:off x="5221224" y="1920240"/>
+            <a:ext cx="1737360" cy="3840480"/>
           </a:xfrm>
           <a:prstGeom prst="rect">
             <a:avLst/>
@@ -6580,8 +6068,127 @@
           </a:bodyPr>
           <a:lstStyle/>
           <a:p>
-            <a:pPr>
-              <a:defRPr sz="1300" b="1">
+            <a:pPr algn="ctr">
+              <a:defRPr sz="2600" b="1">
+                <a:solidFill>
+                  <a:srgbClr val="10B981"/>
+                </a:solidFill>
+                <a:latin typeface="Segoe UI"/>
+              </a:defRPr>
+            </a:pPr>
+            <a:r>
+              <a:t>512 MB</a:t>
+            </a:r>
+          </a:p>
+          <a:p>
+            <a:pPr algn="ctr">
+              <a:spcBef>
+                <a:spcPts val="800"/>
+              </a:spcBef>
+              <a:defRPr sz="1200" b="1">
+                <a:solidFill>
+                  <a:srgbClr val="FFFFFF"/>
+                </a:solidFill>
+              </a:defRPr>
+            </a:pPr>
+            <a:r>
+              <a:t>Render API Service</a:t>
+            </a:r>
+          </a:p>
+          <a:p>
+            <a:pPr algn="ctr">
+              <a:spcBef>
+                <a:spcPts val="1400"/>
+              </a:spcBef>
+              <a:defRPr sz="1100">
+                <a:solidFill>
+                  <a:srgbClr val="94A3B8"/>
+                </a:solidFill>
+              </a:defRPr>
+            </a:pPr>
+            <a:r>
+              <a:t>Node.js 22+ &amp; Express</a:t>
+            </a:r>
+            <a:br/>
+            <a:r>
+              <a:t>REST API &amp; WebSockets</a:t>
+            </a:r>
+            <a:br/>
+            <a:r>
+              <a:t>750 free hours/month</a:t>
+            </a:r>
+          </a:p>
+        </p:txBody>
+      </p:sp>
+      <p:sp>
+        <p:nvSpPr>
+          <p:cNvPr id="11" name="Rounded Rectangle 10"/>
+          <p:cNvSpPr/>
+          <p:nvPr/>
+        </p:nvSpPr>
+        <p:spPr>
+          <a:xfrm>
+            <a:off x="7260336" y="1645920"/>
+            <a:ext cx="2011680" cy="4389120"/>
+          </a:xfrm>
+          <a:prstGeom prst="roundRect">
+            <a:avLst/>
+          </a:prstGeom>
+          <a:solidFill>
+            <a:srgbClr val="1E293B"/>
+          </a:solidFill>
+          <a:ln>
+            <a:solidFill>
+              <a:srgbClr val="334155"/>
+            </a:solidFill>
+          </a:ln>
+        </p:spPr>
+        <p:style>
+          <a:lnRef idx="1">
+            <a:schemeClr val="accent1"/>
+          </a:lnRef>
+          <a:fillRef idx="3">
+            <a:schemeClr val="accent1"/>
+          </a:fillRef>
+          <a:effectRef idx="2">
+            <a:schemeClr val="accent1"/>
+          </a:effectRef>
+          <a:fontRef idx="minor">
+            <a:schemeClr val="lt1"/>
+          </a:fontRef>
+        </p:style>
+        <p:txBody>
+          <a:bodyPr rtlCol="0" anchor="ctr"/>
+          <a:lstStyle/>
+          <a:p>
+            <a:pPr algn="ctr"/>
+          </a:p>
+        </p:txBody>
+      </p:sp>
+      <p:sp>
+        <p:nvSpPr>
+          <p:cNvPr id="12" name="TextBox 11"/>
+          <p:cNvSpPr txBox="1"/>
+          <p:nvPr/>
+        </p:nvSpPr>
+        <p:spPr>
+          <a:xfrm>
+            <a:off x="7397496" y="1920240"/>
+            <a:ext cx="1737360" cy="3840480"/>
+          </a:xfrm>
+          <a:prstGeom prst="rect">
+            <a:avLst/>
+          </a:prstGeom>
+          <a:noFill/>
+        </p:spPr>
+        <p:txBody>
+          <a:bodyPr wrap="square">
+            <a:spAutoFit/>
+          </a:bodyPr>
+          <a:lstStyle/>
+          <a:p>
+            <a:pPr algn="ctr">
+              <a:defRPr sz="2600" b="1">
                 <a:solidFill>
                   <a:srgbClr val="F43F5E"/>
                 </a:solidFill>
@@ -6589,172 +6196,164 @@
               </a:defRPr>
             </a:pPr>
             <a:r>
-              <a:t>Live Production Links</a:t>
-            </a:r>
-          </a:p>
-          <a:p>
-            <a:pPr>
-              <a:spcBef>
-                <a:spcPts val="400"/>
-              </a:spcBef>
-              <a:defRPr sz="1100">
-                <a:solidFill>
-                  <a:srgbClr val="E2E8F0"/>
-                </a:solidFill>
-              </a:defRPr>
-            </a:pPr>
-            <a:r>
-              <a:t>• Frontend Web Application:</a:t>
-            </a:r>
-          </a:p>
-          <a:p>
-            <a:pPr>
-              <a:spcBef>
-                <a:spcPts val="400"/>
-              </a:spcBef>
-              <a:defRPr sz="1100">
-                <a:solidFill>
-                  <a:srgbClr val="E2E8F0"/>
-                </a:solidFill>
-              </a:defRPr>
-            </a:pPr>
-            <a:r>
-              <a:t>•   https://quickshare-nbkr.vercel.app/</a:t>
-            </a:r>
-          </a:p>
-          <a:p>
-            <a:pPr>
-              <a:spcBef>
-                <a:spcPts val="400"/>
-              </a:spcBef>
-              <a:defRPr sz="1100">
-                <a:solidFill>
-                  <a:srgbClr val="E2E8F0"/>
-                </a:solidFill>
-              </a:defRPr>
-            </a:pPr>
-            <a:r>
-              <a:t>• </a:t>
-            </a:r>
-          </a:p>
-          <a:p>
-            <a:pPr>
-              <a:spcBef>
-                <a:spcPts val="400"/>
-              </a:spcBef>
-              <a:defRPr sz="1100">
-                <a:solidFill>
-                  <a:srgbClr val="E2E8F0"/>
-                </a:solidFill>
-              </a:defRPr>
-            </a:pPr>
-            <a:r>
-              <a:t>• Backend REST API Service:</a:t>
-            </a:r>
-          </a:p>
-          <a:p>
-            <a:pPr>
-              <a:spcBef>
-                <a:spcPts val="400"/>
-              </a:spcBef>
-              <a:defRPr sz="1100">
-                <a:solidFill>
-                  <a:srgbClr val="E2E8F0"/>
-                </a:solidFill>
-              </a:defRPr>
-            </a:pPr>
-            <a:r>
-              <a:t>•   https://share-api-0xvn.onrender.com/api</a:t>
-            </a:r>
-          </a:p>
-          <a:p>
-            <a:pPr>
-              <a:spcBef>
-                <a:spcPts val="400"/>
-              </a:spcBef>
-              <a:defRPr sz="1100">
-                <a:solidFill>
-                  <a:srgbClr val="E2E8F0"/>
-                </a:solidFill>
-              </a:defRPr>
-            </a:pPr>
-            <a:r>
-              <a:t>• </a:t>
-            </a:r>
-          </a:p>
-          <a:p>
-            <a:pPr>
-              <a:spcBef>
-                <a:spcPts val="400"/>
-              </a:spcBef>
-              <a:defRPr sz="1100">
-                <a:solidFill>
-                  <a:srgbClr val="E2E8F0"/>
-                </a:solidFill>
-              </a:defRPr>
-            </a:pPr>
-            <a:r>
-              <a:t>• API Health Check:</a:t>
-            </a:r>
-          </a:p>
-          <a:p>
-            <a:pPr>
-              <a:spcBef>
-                <a:spcPts val="400"/>
-              </a:spcBef>
-              <a:defRPr sz="1100">
-                <a:solidFill>
-                  <a:srgbClr val="E2E8F0"/>
-                </a:solidFill>
-              </a:defRPr>
-            </a:pPr>
-            <a:r>
-              <a:t>•   https://share-api-0xvn.onrender.com/api/health</a:t>
-            </a:r>
-          </a:p>
-          <a:p>
-            <a:pPr>
-              <a:spcBef>
-                <a:spcPts val="400"/>
-              </a:spcBef>
-              <a:defRPr sz="1100">
-                <a:solidFill>
-                  <a:srgbClr val="E2E8F0"/>
-                </a:solidFill>
-              </a:defRPr>
-            </a:pPr>
-            <a:r>
-              <a:t>• </a:t>
-            </a:r>
-          </a:p>
-          <a:p>
-            <a:pPr>
-              <a:spcBef>
-                <a:spcPts val="400"/>
-              </a:spcBef>
-              <a:defRPr sz="1100">
-                <a:solidFill>
-                  <a:srgbClr val="E2E8F0"/>
-                </a:solidFill>
-              </a:defRPr>
-            </a:pPr>
-            <a:r>
-              <a:t>• GitHub Open-Source Repository:</a:t>
-            </a:r>
-          </a:p>
-          <a:p>
-            <a:pPr>
-              <a:spcBef>
-                <a:spcPts val="400"/>
-              </a:spcBef>
-              <a:defRPr sz="1100">
-                <a:solidFill>
-                  <a:srgbClr val="E2E8F0"/>
-                </a:solidFill>
-              </a:defRPr>
-            </a:pPr>
-            <a:r>
-              <a:t>•   https://github.com/sathidevivaraprasadreddy/share</a:t>
+              <a:t>5 GB</a:t>
+            </a:r>
+          </a:p>
+          <a:p>
+            <a:pPr algn="ctr">
+              <a:spcBef>
+                <a:spcPts val="800"/>
+              </a:spcBef>
+              <a:defRPr sz="1200" b="1">
+                <a:solidFill>
+                  <a:srgbClr val="FFFFFF"/>
+                </a:solidFill>
+              </a:defRPr>
+            </a:pPr>
+            <a:r>
+              <a:t>TiDB Serverless</a:t>
+            </a:r>
+          </a:p>
+          <a:p>
+            <a:pPr algn="ctr">
+              <a:spcBef>
+                <a:spcPts val="1400"/>
+              </a:spcBef>
+              <a:defRPr sz="1100">
+                <a:solidFill>
+                  <a:srgbClr val="94A3B8"/>
+                </a:solidFill>
+              </a:defRPr>
+            </a:pPr>
+            <a:r>
+              <a:t>Cloud MySQL 8 engine</a:t>
+            </a:r>
+            <a:br/>
+            <a:r>
+              <a:t>50M Request Units/month</a:t>
+            </a:r>
+            <a:br/>
+            <a:r>
+              <a:t>Dual SQLite dev driver</a:t>
+            </a:r>
+          </a:p>
+        </p:txBody>
+      </p:sp>
+      <p:sp>
+        <p:nvSpPr>
+          <p:cNvPr id="13" name="Rounded Rectangle 12"/>
+          <p:cNvSpPr/>
+          <p:nvPr/>
+        </p:nvSpPr>
+        <p:spPr>
+          <a:xfrm>
+            <a:off x="9436608" y="1645920"/>
+            <a:ext cx="2011680" cy="4389120"/>
+          </a:xfrm>
+          <a:prstGeom prst="roundRect">
+            <a:avLst/>
+          </a:prstGeom>
+          <a:solidFill>
+            <a:srgbClr val="1E293B"/>
+          </a:solidFill>
+          <a:ln>
+            <a:solidFill>
+              <a:srgbClr val="334155"/>
+            </a:solidFill>
+          </a:ln>
+        </p:spPr>
+        <p:style>
+          <a:lnRef idx="1">
+            <a:schemeClr val="accent1"/>
+          </a:lnRef>
+          <a:fillRef idx="3">
+            <a:schemeClr val="accent1"/>
+          </a:fillRef>
+          <a:effectRef idx="2">
+            <a:schemeClr val="accent1"/>
+          </a:effectRef>
+          <a:fontRef idx="minor">
+            <a:schemeClr val="lt1"/>
+          </a:fontRef>
+        </p:style>
+        <p:txBody>
+          <a:bodyPr rtlCol="0" anchor="ctr"/>
+          <a:lstStyle/>
+          <a:p>
+            <a:pPr algn="ctr"/>
+          </a:p>
+        </p:txBody>
+      </p:sp>
+      <p:sp>
+        <p:nvSpPr>
+          <p:cNvPr id="14" name="TextBox 13"/>
+          <p:cNvSpPr txBox="1"/>
+          <p:nvPr/>
+        </p:nvSpPr>
+        <p:spPr>
+          <a:xfrm>
+            <a:off x="9573768" y="1920240"/>
+            <a:ext cx="1737360" cy="3840480"/>
+          </a:xfrm>
+          <a:prstGeom prst="rect">
+            <a:avLst/>
+          </a:prstGeom>
+          <a:noFill/>
+        </p:spPr>
+        <p:txBody>
+          <a:bodyPr wrap="square">
+            <a:spAutoFit/>
+          </a:bodyPr>
+          <a:lstStyle/>
+          <a:p>
+            <a:pPr algn="ctr">
+              <a:defRPr sz="2600" b="1">
+                <a:solidFill>
+                  <a:srgbClr val="818CF8"/>
+                </a:solidFill>
+                <a:latin typeface="Segoe UI"/>
+              </a:defRPr>
+            </a:pPr>
+            <a:r>
+              <a:t>1 GB</a:t>
+            </a:r>
+          </a:p>
+          <a:p>
+            <a:pPr algn="ctr">
+              <a:spcBef>
+                <a:spcPts val="800"/>
+              </a:spcBef>
+              <a:defRPr sz="1200" b="1">
+                <a:solidFill>
+                  <a:srgbClr val="FFFFFF"/>
+                </a:solidFill>
+              </a:defRPr>
+            </a:pPr>
+            <a:r>
+              <a:t>Supabase S3 Storage</a:t>
+            </a:r>
+          </a:p>
+          <a:p>
+            <a:pPr algn="ctr">
+              <a:spcBef>
+                <a:spcPts val="1400"/>
+              </a:spcBef>
+              <a:defRPr sz="1100">
+                <a:solidFill>
+                  <a:srgbClr val="94A3B8"/>
+                </a:solidFill>
+              </a:defRPr>
+            </a:pPr>
+            <a:r>
+              <a:t>S3-compatible bucket</a:t>
+            </a:r>
+            <a:br/>
+            <a:r>
+              <a:t>Streaming downloads</a:t>
+            </a:r>
+            <a:br/>
+            <a:r>
+              <a:t>Automated purge cron</a:t>
             </a:r>
           </a:p>
         </p:txBody>
@@ -6768,6 +6367,758 @@
 </file>
 
 <file path=ppt/slides/slide17.xml><?xml version="1.0" encoding="utf-8"?>
+<p:sld xmlns:a="http://schemas.openxmlformats.org/drawingml/2006/main" xmlns:p="http://schemas.openxmlformats.org/presentationml/2006/main" xmlns:r="http://schemas.openxmlformats.org/officeDocument/2006/relationships">
+  <p:cSld>
+    <p:spTree>
+      <p:nvGrpSpPr>
+        <p:cNvPr id="1" name=""/>
+        <p:cNvGrpSpPr/>
+        <p:nvPr/>
+      </p:nvGrpSpPr>
+      <p:grpSpPr/>
+      <p:sp>
+        <p:nvSpPr>
+          <p:cNvPr id="2" name="Rectangle 1"/>
+          <p:cNvSpPr/>
+          <p:nvPr/>
+        </p:nvSpPr>
+        <p:spPr>
+          <a:xfrm>
+            <a:off x="0" y="0"/>
+            <a:ext cx="12191695" cy="6858000"/>
+          </a:xfrm>
+          <a:prstGeom prst="rect">
+            <a:avLst/>
+          </a:prstGeom>
+          <a:solidFill>
+            <a:srgbClr val="0F172A"/>
+          </a:solidFill>
+          <a:ln>
+            <a:noFill/>
+          </a:ln>
+        </p:spPr>
+        <p:style>
+          <a:lnRef idx="1">
+            <a:schemeClr val="accent1"/>
+          </a:lnRef>
+          <a:fillRef idx="3">
+            <a:schemeClr val="accent1"/>
+          </a:fillRef>
+          <a:effectRef idx="2">
+            <a:schemeClr val="accent1"/>
+          </a:effectRef>
+          <a:fontRef idx="minor">
+            <a:schemeClr val="lt1"/>
+          </a:fontRef>
+        </p:style>
+        <p:txBody>
+          <a:bodyPr rtlCol="0" anchor="ctr"/>
+          <a:lstStyle/>
+          <a:p>
+            <a:pPr algn="ctr"/>
+          </a:p>
+        </p:txBody>
+      </p:sp>
+      <p:sp>
+        <p:nvSpPr>
+          <p:cNvPr id="3" name="TextBox 2"/>
+          <p:cNvSpPr txBox="1"/>
+          <p:nvPr/>
+        </p:nvSpPr>
+        <p:spPr>
+          <a:xfrm>
+            <a:off x="731520" y="365760"/>
+            <a:ext cx="10515600" cy="320040"/>
+          </a:xfrm>
+          <a:prstGeom prst="rect">
+            <a:avLst/>
+          </a:prstGeom>
+          <a:noFill/>
+        </p:spPr>
+        <p:txBody>
+          <a:bodyPr wrap="square">
+            <a:spAutoFit/>
+          </a:bodyPr>
+          <a:lstStyle/>
+          <a:p>
+            <a:pPr>
+              <a:defRPr sz="1100" b="1">
+                <a:solidFill>
+                  <a:srgbClr val="F43F5E"/>
+                </a:solidFill>
+                <a:latin typeface="Segoe UI"/>
+              </a:defRPr>
+            </a:pPr>
+            <a:r>
+              <a:t>PRODUCTION VERIFICATION</a:t>
+            </a:r>
+          </a:p>
+        </p:txBody>
+      </p:sp>
+      <p:sp>
+        <p:nvSpPr>
+          <p:cNvPr id="4" name="TextBox 3"/>
+          <p:cNvSpPr txBox="1"/>
+          <p:nvPr/>
+        </p:nvSpPr>
+        <p:spPr>
+          <a:xfrm>
+            <a:off x="731520" y="658368"/>
+            <a:ext cx="10515600" cy="594360"/>
+          </a:xfrm>
+          <a:prstGeom prst="rect">
+            <a:avLst/>
+          </a:prstGeom>
+          <a:noFill/>
+        </p:spPr>
+        <p:txBody>
+          <a:bodyPr wrap="square">
+            <a:spAutoFit/>
+          </a:bodyPr>
+          <a:lstStyle/>
+          <a:p>
+            <a:pPr>
+              <a:defRPr sz="2200" b="1">
+                <a:solidFill>
+                  <a:srgbClr val="FFFFFF"/>
+                </a:solidFill>
+                <a:latin typeface="Segoe UI"/>
+              </a:defRPr>
+            </a:pPr>
+            <a:r>
+              <a:t>Automated Testing &amp; Live Deployment Proof</a:t>
+            </a:r>
+          </a:p>
+          <a:p>
+            <a:pPr>
+              <a:spcBef>
+                <a:spcPts val="300"/>
+              </a:spcBef>
+              <a:defRPr sz="1200">
+                <a:solidFill>
+                  <a:srgbClr val="94A3B8"/>
+                </a:solidFill>
+                <a:latin typeface="Segoe UI"/>
+              </a:defRPr>
+            </a:pPr>
+            <a:r>
+              <a:t>Validated through comprehensive test suites and active cloud deployment.</a:t>
+            </a:r>
+          </a:p>
+        </p:txBody>
+      </p:sp>
+      <p:sp>
+        <p:nvSpPr>
+          <p:cNvPr id="5" name="Rounded Rectangle 4"/>
+          <p:cNvSpPr/>
+          <p:nvPr/>
+        </p:nvSpPr>
+        <p:spPr>
+          <a:xfrm>
+            <a:off x="731520" y="1645920"/>
+            <a:ext cx="3383280" cy="4389120"/>
+          </a:xfrm>
+          <a:prstGeom prst="roundRect">
+            <a:avLst/>
+          </a:prstGeom>
+          <a:solidFill>
+            <a:srgbClr val="1E293B"/>
+          </a:solidFill>
+          <a:ln>
+            <a:solidFill>
+              <a:srgbClr val="334155"/>
+            </a:solidFill>
+          </a:ln>
+        </p:spPr>
+        <p:style>
+          <a:lnRef idx="1">
+            <a:schemeClr val="accent1"/>
+          </a:lnRef>
+          <a:fillRef idx="3">
+            <a:schemeClr val="accent1"/>
+          </a:fillRef>
+          <a:effectRef idx="2">
+            <a:schemeClr val="accent1"/>
+          </a:effectRef>
+          <a:fontRef idx="minor">
+            <a:schemeClr val="lt1"/>
+          </a:fontRef>
+        </p:style>
+        <p:txBody>
+          <a:bodyPr rtlCol="0" anchor="ctr"/>
+          <a:lstStyle/>
+          <a:p>
+            <a:pPr algn="ctr"/>
+          </a:p>
+        </p:txBody>
+      </p:sp>
+      <p:sp>
+        <p:nvSpPr>
+          <p:cNvPr id="6" name="TextBox 5"/>
+          <p:cNvSpPr txBox="1"/>
+          <p:nvPr/>
+        </p:nvSpPr>
+        <p:spPr>
+          <a:xfrm>
+            <a:off x="960120" y="1828800"/>
+            <a:ext cx="2926080" cy="4023360"/>
+          </a:xfrm>
+          <a:prstGeom prst="rect">
+            <a:avLst/>
+          </a:prstGeom>
+          <a:noFill/>
+        </p:spPr>
+        <p:txBody>
+          <a:bodyPr wrap="square">
+            <a:spAutoFit/>
+          </a:bodyPr>
+          <a:lstStyle/>
+          <a:p>
+            <a:pPr>
+              <a:defRPr sz="1300" b="1">
+                <a:solidFill>
+                  <a:srgbClr val="10B981"/>
+                </a:solidFill>
+                <a:latin typeface="Segoe UI"/>
+              </a:defRPr>
+            </a:pPr>
+            <a:r>
+              <a:t>Automated Test Coverage</a:t>
+            </a:r>
+          </a:p>
+          <a:p>
+            <a:pPr>
+              <a:spcBef>
+                <a:spcPts val="400"/>
+              </a:spcBef>
+              <a:defRPr sz="1100">
+                <a:solidFill>
+                  <a:srgbClr val="E2E8F0"/>
+                </a:solidFill>
+              </a:defRPr>
+            </a:pPr>
+            <a:r>
+              <a:t>• 53 / 53 Jest automated platform tests passing (100%).</a:t>
+            </a:r>
+          </a:p>
+          <a:p>
+            <a:pPr>
+              <a:spcBef>
+                <a:spcPts val="400"/>
+              </a:spcBef>
+              <a:defRPr sz="1100">
+                <a:solidFill>
+                  <a:srgbClr val="E2E8F0"/>
+                </a:solidFill>
+              </a:defRPr>
+            </a:pPr>
+            <a:r>
+              <a:t>• Authentication: Registration, bcrypt hashing, JWT issuance.</a:t>
+            </a:r>
+          </a:p>
+          <a:p>
+            <a:pPr>
+              <a:spcBef>
+                <a:spcPts val="400"/>
+              </a:spcBef>
+              <a:defRPr sz="1100">
+                <a:solidFill>
+                  <a:srgbClr val="E2E8F0"/>
+                </a:solidFill>
+              </a:defRPr>
+            </a:pPr>
+            <a:r>
+              <a:t>• Upload engine: File sanitization, SHA-256 hashes, size quotas.</a:t>
+            </a:r>
+          </a:p>
+          <a:p>
+            <a:pPr>
+              <a:spcBef>
+                <a:spcPts val="400"/>
+              </a:spcBef>
+              <a:defRPr sz="1100">
+                <a:solidFill>
+                  <a:srgbClr val="E2E8F0"/>
+                </a:solidFill>
+              </a:defRPr>
+            </a:pPr>
+            <a:r>
+              <a:t>• 6-Digit codes: Code lookup, rate limiting, and expiry lockout.</a:t>
+            </a:r>
+          </a:p>
+          <a:p>
+            <a:pPr>
+              <a:spcBef>
+                <a:spcPts val="400"/>
+              </a:spcBef>
+              <a:defRPr sz="1100">
+                <a:solidFill>
+                  <a:srgbClr val="E2E8F0"/>
+                </a:solidFill>
+              </a:defRPr>
+            </a:pPr>
+            <a:r>
+              <a:t>• Direct inboxes: Delivery checkmarks and view updates.</a:t>
+            </a:r>
+          </a:p>
+          <a:p>
+            <a:pPr>
+              <a:spcBef>
+                <a:spcPts val="400"/>
+              </a:spcBef>
+              <a:defRPr sz="1100">
+                <a:solidFill>
+                  <a:srgbClr val="E2E8F0"/>
+                </a:solidFill>
+              </a:defRPr>
+            </a:pPr>
+            <a:r>
+              <a:t>• File drive: Inline rename, trash soft-delete, and restore.</a:t>
+            </a:r>
+          </a:p>
+          <a:p>
+            <a:pPr>
+              <a:spcBef>
+                <a:spcPts val="400"/>
+              </a:spcBef>
+              <a:defRPr sz="1100">
+                <a:solidFill>
+                  <a:srgbClr val="E2E8F0"/>
+                </a:solidFill>
+              </a:defRPr>
+            </a:pPr>
+            <a:r>
+              <a:t>• Group collaboration: Chat messages, roles, and file deletion.</a:t>
+            </a:r>
+          </a:p>
+        </p:txBody>
+      </p:sp>
+      <p:sp>
+        <p:nvSpPr>
+          <p:cNvPr id="7" name="Rounded Rectangle 6"/>
+          <p:cNvSpPr/>
+          <p:nvPr/>
+        </p:nvSpPr>
+        <p:spPr>
+          <a:xfrm>
+            <a:off x="4389120" y="1645920"/>
+            <a:ext cx="3383280" cy="4389120"/>
+          </a:xfrm>
+          <a:prstGeom prst="roundRect">
+            <a:avLst/>
+          </a:prstGeom>
+          <a:solidFill>
+            <a:srgbClr val="1E293B"/>
+          </a:solidFill>
+          <a:ln>
+            <a:solidFill>
+              <a:srgbClr val="334155"/>
+            </a:solidFill>
+          </a:ln>
+        </p:spPr>
+        <p:style>
+          <a:lnRef idx="1">
+            <a:schemeClr val="accent1"/>
+          </a:lnRef>
+          <a:fillRef idx="3">
+            <a:schemeClr val="accent1"/>
+          </a:fillRef>
+          <a:effectRef idx="2">
+            <a:schemeClr val="accent1"/>
+          </a:effectRef>
+          <a:fontRef idx="minor">
+            <a:schemeClr val="lt1"/>
+          </a:fontRef>
+        </p:style>
+        <p:txBody>
+          <a:bodyPr rtlCol="0" anchor="ctr"/>
+          <a:lstStyle/>
+          <a:p>
+            <a:pPr algn="ctr"/>
+          </a:p>
+        </p:txBody>
+      </p:sp>
+      <p:sp>
+        <p:nvSpPr>
+          <p:cNvPr id="8" name="TextBox 7"/>
+          <p:cNvSpPr txBox="1"/>
+          <p:nvPr/>
+        </p:nvSpPr>
+        <p:spPr>
+          <a:xfrm>
+            <a:off x="4617720" y="1828800"/>
+            <a:ext cx="2926080" cy="4023360"/>
+          </a:xfrm>
+          <a:prstGeom prst="rect">
+            <a:avLst/>
+          </a:prstGeom>
+          <a:noFill/>
+        </p:spPr>
+        <p:txBody>
+          <a:bodyPr wrap="square">
+            <a:spAutoFit/>
+          </a:bodyPr>
+          <a:lstStyle/>
+          <a:p>
+            <a:pPr>
+              <a:defRPr sz="1300" b="1">
+                <a:solidFill>
+                  <a:srgbClr val="818CF8"/>
+                </a:solidFill>
+                <a:latin typeface="Segoe UI"/>
+              </a:defRPr>
+            </a:pPr>
+            <a:r>
+              <a:t>Security Verification</a:t>
+            </a:r>
+          </a:p>
+          <a:p>
+            <a:pPr>
+              <a:spcBef>
+                <a:spcPts val="400"/>
+              </a:spcBef>
+              <a:defRPr sz="1100">
+                <a:solidFill>
+                  <a:srgbClr val="E2E8F0"/>
+                </a:solidFill>
+              </a:defRPr>
+            </a:pPr>
+            <a:r>
+              <a:t>• High-entropy tokens: 128-bit share tokens (crypto.randomBytes).</a:t>
+            </a:r>
+          </a:p>
+          <a:p>
+            <a:pPr>
+              <a:spcBef>
+                <a:spcPts val="400"/>
+              </a:spcBef>
+              <a:defRPr sz="1100">
+                <a:solidFill>
+                  <a:srgbClr val="E2E8F0"/>
+                </a:solidFill>
+              </a:defRPr>
+            </a:pPr>
+            <a:r>
+              <a:t>• Owner secret key: 192-bit private token for physical purge.</a:t>
+            </a:r>
+          </a:p>
+          <a:p>
+            <a:pPr>
+              <a:spcBef>
+                <a:spcPts val="400"/>
+              </a:spcBef>
+              <a:defRPr sz="1100">
+                <a:solidFill>
+                  <a:srgbClr val="E2E8F0"/>
+                </a:solidFill>
+              </a:defRPr>
+            </a:pPr>
+            <a:r>
+              <a:t>• Immediate physical purge: Revocation returns HTTP 410 Gone.</a:t>
+            </a:r>
+          </a:p>
+          <a:p>
+            <a:pPr>
+              <a:spcBef>
+                <a:spcPts val="400"/>
+              </a:spcBef>
+              <a:defRPr sz="1100">
+                <a:solidFill>
+                  <a:srgbClr val="E2E8F0"/>
+                </a:solidFill>
+              </a:defRPr>
+            </a:pPr>
+            <a:r>
+              <a:t>• File blocklist: Blocks .exe, .bat, .sh, .vbs, .msi, and .php.</a:t>
+            </a:r>
+          </a:p>
+          <a:p>
+            <a:pPr>
+              <a:spcBef>
+                <a:spcPts val="400"/>
+              </a:spcBef>
+              <a:defRPr sz="1100">
+                <a:solidFill>
+                  <a:srgbClr val="E2E8F0"/>
+                </a:solidFill>
+              </a:defRPr>
+            </a:pPr>
+            <a:r>
+              <a:t>• Parameterized queries: 100% protection against SQL injection.</a:t>
+            </a:r>
+          </a:p>
+          <a:p>
+            <a:pPr>
+              <a:spcBef>
+                <a:spcPts val="400"/>
+              </a:spcBef>
+              <a:defRPr sz="1100">
+                <a:solidFill>
+                  <a:srgbClr val="E2E8F0"/>
+                </a:solidFill>
+              </a:defRPr>
+            </a:pPr>
+            <a:r>
+              <a:t>• Path traversal protection: Strict resolution against upload roots.</a:t>
+            </a:r>
+          </a:p>
+        </p:txBody>
+      </p:sp>
+      <p:sp>
+        <p:nvSpPr>
+          <p:cNvPr id="9" name="Rounded Rectangle 8"/>
+          <p:cNvSpPr/>
+          <p:nvPr/>
+        </p:nvSpPr>
+        <p:spPr>
+          <a:xfrm>
+            <a:off x="8046720" y="1645920"/>
+            <a:ext cx="3383280" cy="4389120"/>
+          </a:xfrm>
+          <a:prstGeom prst="roundRect">
+            <a:avLst/>
+          </a:prstGeom>
+          <a:solidFill>
+            <a:srgbClr val="1E293B"/>
+          </a:solidFill>
+          <a:ln>
+            <a:solidFill>
+              <a:srgbClr val="334155"/>
+            </a:solidFill>
+          </a:ln>
+        </p:spPr>
+        <p:style>
+          <a:lnRef idx="1">
+            <a:schemeClr val="accent1"/>
+          </a:lnRef>
+          <a:fillRef idx="3">
+            <a:schemeClr val="accent1"/>
+          </a:fillRef>
+          <a:effectRef idx="2">
+            <a:schemeClr val="accent1"/>
+          </a:effectRef>
+          <a:fontRef idx="minor">
+            <a:schemeClr val="lt1"/>
+          </a:fontRef>
+        </p:style>
+        <p:txBody>
+          <a:bodyPr rtlCol="0" anchor="ctr"/>
+          <a:lstStyle/>
+          <a:p>
+            <a:pPr algn="ctr"/>
+          </a:p>
+        </p:txBody>
+      </p:sp>
+      <p:sp>
+        <p:nvSpPr>
+          <p:cNvPr id="10" name="TextBox 9"/>
+          <p:cNvSpPr txBox="1"/>
+          <p:nvPr/>
+        </p:nvSpPr>
+        <p:spPr>
+          <a:xfrm>
+            <a:off x="8275320" y="1828800"/>
+            <a:ext cx="2926080" cy="4023360"/>
+          </a:xfrm>
+          <a:prstGeom prst="rect">
+            <a:avLst/>
+          </a:prstGeom>
+          <a:noFill/>
+        </p:spPr>
+        <p:txBody>
+          <a:bodyPr wrap="square">
+            <a:spAutoFit/>
+          </a:bodyPr>
+          <a:lstStyle/>
+          <a:p>
+            <a:pPr>
+              <a:defRPr sz="1300" b="1">
+                <a:solidFill>
+                  <a:srgbClr val="F43F5E"/>
+                </a:solidFill>
+                <a:latin typeface="Segoe UI"/>
+              </a:defRPr>
+            </a:pPr>
+            <a:r>
+              <a:t>Live Production Links</a:t>
+            </a:r>
+          </a:p>
+          <a:p>
+            <a:pPr>
+              <a:spcBef>
+                <a:spcPts val="400"/>
+              </a:spcBef>
+              <a:defRPr sz="1100">
+                <a:solidFill>
+                  <a:srgbClr val="E2E8F0"/>
+                </a:solidFill>
+              </a:defRPr>
+            </a:pPr>
+            <a:r>
+              <a:t>• Frontend Web Application:</a:t>
+            </a:r>
+          </a:p>
+          <a:p>
+            <a:pPr>
+              <a:spcBef>
+                <a:spcPts val="400"/>
+              </a:spcBef>
+              <a:defRPr sz="1100">
+                <a:solidFill>
+                  <a:srgbClr val="E2E8F0"/>
+                </a:solidFill>
+              </a:defRPr>
+            </a:pPr>
+            <a:r>
+              <a:t>•   https://quickshare-nbkr.vercel.app/</a:t>
+            </a:r>
+          </a:p>
+          <a:p>
+            <a:pPr>
+              <a:spcBef>
+                <a:spcPts val="400"/>
+              </a:spcBef>
+              <a:defRPr sz="1100">
+                <a:solidFill>
+                  <a:srgbClr val="E2E8F0"/>
+                </a:solidFill>
+              </a:defRPr>
+            </a:pPr>
+            <a:r>
+              <a:t>• </a:t>
+            </a:r>
+          </a:p>
+          <a:p>
+            <a:pPr>
+              <a:spcBef>
+                <a:spcPts val="400"/>
+              </a:spcBef>
+              <a:defRPr sz="1100">
+                <a:solidFill>
+                  <a:srgbClr val="E2E8F0"/>
+                </a:solidFill>
+              </a:defRPr>
+            </a:pPr>
+            <a:r>
+              <a:t>• Backend REST API Service:</a:t>
+            </a:r>
+          </a:p>
+          <a:p>
+            <a:pPr>
+              <a:spcBef>
+                <a:spcPts val="400"/>
+              </a:spcBef>
+              <a:defRPr sz="1100">
+                <a:solidFill>
+                  <a:srgbClr val="E2E8F0"/>
+                </a:solidFill>
+              </a:defRPr>
+            </a:pPr>
+            <a:r>
+              <a:t>•   https://share-api-0xvn.onrender.com/api</a:t>
+            </a:r>
+          </a:p>
+          <a:p>
+            <a:pPr>
+              <a:spcBef>
+                <a:spcPts val="400"/>
+              </a:spcBef>
+              <a:defRPr sz="1100">
+                <a:solidFill>
+                  <a:srgbClr val="E2E8F0"/>
+                </a:solidFill>
+              </a:defRPr>
+            </a:pPr>
+            <a:r>
+              <a:t>• </a:t>
+            </a:r>
+          </a:p>
+          <a:p>
+            <a:pPr>
+              <a:spcBef>
+                <a:spcPts val="400"/>
+              </a:spcBef>
+              <a:defRPr sz="1100">
+                <a:solidFill>
+                  <a:srgbClr val="E2E8F0"/>
+                </a:solidFill>
+              </a:defRPr>
+            </a:pPr>
+            <a:r>
+              <a:t>• API Health Check:</a:t>
+            </a:r>
+          </a:p>
+          <a:p>
+            <a:pPr>
+              <a:spcBef>
+                <a:spcPts val="400"/>
+              </a:spcBef>
+              <a:defRPr sz="1100">
+                <a:solidFill>
+                  <a:srgbClr val="E2E8F0"/>
+                </a:solidFill>
+              </a:defRPr>
+            </a:pPr>
+            <a:r>
+              <a:t>•   https://share-api-0xvn.onrender.com/api/health</a:t>
+            </a:r>
+          </a:p>
+          <a:p>
+            <a:pPr>
+              <a:spcBef>
+                <a:spcPts val="400"/>
+              </a:spcBef>
+              <a:defRPr sz="1100">
+                <a:solidFill>
+                  <a:srgbClr val="E2E8F0"/>
+                </a:solidFill>
+              </a:defRPr>
+            </a:pPr>
+            <a:r>
+              <a:t>• </a:t>
+            </a:r>
+          </a:p>
+          <a:p>
+            <a:pPr>
+              <a:spcBef>
+                <a:spcPts val="400"/>
+              </a:spcBef>
+              <a:defRPr sz="1100">
+                <a:solidFill>
+                  <a:srgbClr val="E2E8F0"/>
+                </a:solidFill>
+              </a:defRPr>
+            </a:pPr>
+            <a:r>
+              <a:t>• GitHub Open-Source Repository:</a:t>
+            </a:r>
+          </a:p>
+          <a:p>
+            <a:pPr>
+              <a:spcBef>
+                <a:spcPts val="400"/>
+              </a:spcBef>
+              <a:defRPr sz="1100">
+                <a:solidFill>
+                  <a:srgbClr val="E2E8F0"/>
+                </a:solidFill>
+              </a:defRPr>
+            </a:pPr>
+            <a:r>
+              <a:t>•   https://github.com/sathidevivaraprasadreddy/share</a:t>
+            </a:r>
+          </a:p>
+        </p:txBody>
+      </p:sp>
+    </p:spTree>
+  </p:cSld>
+  <p:clrMapOvr>
+    <a:masterClrMapping/>
+  </p:clrMapOvr>
+</p:sld>
+</file>
+
+<file path=ppt/slides/slide18.xml><?xml version="1.0" encoding="utf-8"?>
 <p:sld xmlns:a="http://schemas.openxmlformats.org/drawingml/2006/main" xmlns:p="http://schemas.openxmlformats.org/presentationml/2006/main" xmlns:r="http://schemas.openxmlformats.org/officeDocument/2006/relationships">
   <p:cSld>
     <p:spTree>

</xml_diff>